<commit_message>
docs(presentation): embed live demo link badges into editable PPTX decks and slide images
</commit_message>
<xml_diff>
--- a/SIH2026_PS26122_Oil_India_Presentation_Editable.pptx
+++ b/SIH2026_PS26122_Oil_India_Presentation_Editable.pptx
@@ -3241,11 +3241,11 @@
           <a:p>
             <a:pPr>
               <a:spcAft>
-                <a:spcPts val="600"/>
+                <a:spcPts val="500"/>
               </a:spcAft>
             </a:pPr>
             <a:r>
-              <a:rPr sz="1200" b="1" u="none">
+              <a:rPr sz="1150" b="1" u="none">
                 <a:solidFill>
                   <a:srgbClr val="C25E00"/>
                 </a:solidFill>
@@ -3254,7 +3254,7 @@
               <a:t>•  </a:t>
             </a:r>
             <a:r>
-              <a:rPr sz="1200" b="1" u="none">
+              <a:rPr sz="1150" b="1" u="none">
                 <a:solidFill>
                   <a:srgbClr val="0B2545"/>
                 </a:solidFill>
@@ -3263,7 +3263,7 @@
               <a:t>Problem Statement ID: </a:t>
             </a:r>
             <a:r>
-              <a:rPr sz="1200" b="0" u="none">
+              <a:rPr sz="1150" b="0" u="none">
                 <a:solidFill>
                   <a:srgbClr val="1E293B"/>
                 </a:solidFill>
@@ -3275,11 +3275,11 @@
           <a:p>
             <a:pPr>
               <a:spcAft>
-                <a:spcPts val="600"/>
+                <a:spcPts val="500"/>
               </a:spcAft>
             </a:pPr>
             <a:r>
-              <a:rPr sz="1200" b="1" u="none">
+              <a:rPr sz="1150" b="1" u="none">
                 <a:solidFill>
                   <a:srgbClr val="C25E00"/>
                 </a:solidFill>
@@ -3288,7 +3288,7 @@
               <a:t>•  </a:t>
             </a:r>
             <a:r>
-              <a:rPr sz="1200" b="1" u="none">
+              <a:rPr sz="1150" b="1" u="none">
                 <a:solidFill>
                   <a:srgbClr val="0B2545"/>
                 </a:solidFill>
@@ -3297,7 +3297,7 @@
               <a:t>Problem Statement Title: </a:t>
             </a:r>
             <a:r>
-              <a:rPr sz="1200" b="0" u="none">
+              <a:rPr sz="1150" b="0" u="none">
                 <a:solidFill>
                   <a:srgbClr val="1E293B"/>
                 </a:solidFill>
@@ -3309,11 +3309,11 @@
           <a:p>
             <a:pPr>
               <a:spcAft>
-                <a:spcPts val="600"/>
+                <a:spcPts val="500"/>
               </a:spcAft>
             </a:pPr>
             <a:r>
-              <a:rPr sz="1200" b="1" u="none">
+              <a:rPr sz="1150" b="1" u="none">
                 <a:solidFill>
                   <a:srgbClr val="C25E00"/>
                 </a:solidFill>
@@ -3322,7 +3322,7 @@
               <a:t>•  </a:t>
             </a:r>
             <a:r>
-              <a:rPr sz="1200" b="1" u="none">
+              <a:rPr sz="1150" b="1" u="none">
                 <a:solidFill>
                   <a:srgbClr val="0B2545"/>
                 </a:solidFill>
@@ -3331,7 +3331,7 @@
               <a:t>Organization: </a:t>
             </a:r>
             <a:r>
-              <a:rPr sz="1200" b="0" u="none">
+              <a:rPr sz="1150" b="0" u="none">
                 <a:solidFill>
                   <a:srgbClr val="1E293B"/>
                 </a:solidFill>
@@ -3343,11 +3343,11 @@
           <a:p>
             <a:pPr>
               <a:spcAft>
-                <a:spcPts val="600"/>
+                <a:spcPts val="500"/>
               </a:spcAft>
             </a:pPr>
             <a:r>
-              <a:rPr sz="1200" b="1" u="none">
+              <a:rPr sz="1150" b="1" u="none">
                 <a:solidFill>
                   <a:srgbClr val="C25E00"/>
                 </a:solidFill>
@@ -3356,7 +3356,7 @@
               <a:t>•  </a:t>
             </a:r>
             <a:r>
-              <a:rPr sz="1200" b="1" u="none">
+              <a:rPr sz="1150" b="1" u="none">
                 <a:solidFill>
                   <a:srgbClr val="0B2545"/>
                 </a:solidFill>
@@ -3365,7 +3365,7 @@
               <a:t>Theme: </a:t>
             </a:r>
             <a:r>
-              <a:rPr sz="1200" b="0" u="none">
+              <a:rPr sz="1150" b="0" u="none">
                 <a:solidFill>
                   <a:srgbClr val="1E293B"/>
                 </a:solidFill>
@@ -3377,11 +3377,11 @@
           <a:p>
             <a:pPr>
               <a:spcAft>
-                <a:spcPts val="600"/>
+                <a:spcPts val="500"/>
               </a:spcAft>
             </a:pPr>
             <a:r>
-              <a:rPr sz="1200" b="1" u="none">
+              <a:rPr sz="1150" b="1" u="none">
                 <a:solidFill>
                   <a:srgbClr val="C25E00"/>
                 </a:solidFill>
@@ -3390,7 +3390,7 @@
               <a:t>•  </a:t>
             </a:r>
             <a:r>
-              <a:rPr sz="1200" b="1" u="none">
+              <a:rPr sz="1150" b="1" u="none">
                 <a:solidFill>
                   <a:srgbClr val="0B2545"/>
                 </a:solidFill>
@@ -3399,7 +3399,7 @@
               <a:t>PS Category: </a:t>
             </a:r>
             <a:r>
-              <a:rPr sz="1200" b="0" u="none">
+              <a:rPr sz="1150" b="0" u="none">
                 <a:solidFill>
                   <a:srgbClr val="1E293B"/>
                 </a:solidFill>
@@ -3411,11 +3411,11 @@
           <a:p>
             <a:pPr>
               <a:spcAft>
-                <a:spcPts val="600"/>
+                <a:spcPts val="500"/>
               </a:spcAft>
             </a:pPr>
             <a:r>
-              <a:rPr sz="1200" b="1" u="none">
+              <a:rPr sz="1150" b="1" u="none">
                 <a:solidFill>
                   <a:srgbClr val="C25E00"/>
                 </a:solidFill>
@@ -3424,7 +3424,7 @@
               <a:t>•  </a:t>
             </a:r>
             <a:r>
-              <a:rPr sz="1200" b="1" u="none">
+              <a:rPr sz="1150" b="1" u="none">
                 <a:solidFill>
                   <a:srgbClr val="0B2545"/>
                 </a:solidFill>
@@ -3433,7 +3433,7 @@
               <a:t>Team ID: </a:t>
             </a:r>
             <a:r>
-              <a:rPr sz="1200" b="0" u="none">
+              <a:rPr sz="1150" b="0" u="none">
                 <a:solidFill>
                   <a:srgbClr val="1E293B"/>
                 </a:solidFill>
@@ -3445,11 +3445,11 @@
           <a:p>
             <a:pPr>
               <a:spcAft>
-                <a:spcPts val="600"/>
+                <a:spcPts val="500"/>
               </a:spcAft>
             </a:pPr>
             <a:r>
-              <a:rPr sz="1200" b="1" u="none">
+              <a:rPr sz="1150" b="1" u="none">
                 <a:solidFill>
                   <a:srgbClr val="C25E00"/>
                 </a:solidFill>
@@ -3458,7 +3458,7 @@
               <a:t>•  </a:t>
             </a:r>
             <a:r>
-              <a:rPr sz="1200" b="1" u="none">
+              <a:rPr sz="1150" b="1" u="none">
                 <a:solidFill>
                   <a:srgbClr val="0B2545"/>
                 </a:solidFill>
@@ -3467,27 +3467,126 @@
               <a:t>Team Name: </a:t>
             </a:r>
             <a:r>
-              <a:rPr sz="1200" b="0" u="none">
+              <a:rPr sz="1150" b="0" u="none">
                 <a:solidFill>
                   <a:srgbClr val="1E293B"/>
                 </a:solidFill>
                 <a:latin typeface="Segoe UI"/>
               </a:rPr>
               <a:t>#TheAnanta Innovators</a:t>
+            </a:r>
+          </a:p>
+          <a:p>
+            <a:pPr>
+              <a:spcAft>
+                <a:spcPts val="500"/>
+              </a:spcAft>
+            </a:pPr>
+            <a:r>
+              <a:rPr sz="1150" b="1" u="none">
+                <a:solidFill>
+                  <a:srgbClr val="C25E00"/>
+                </a:solidFill>
+                <a:latin typeface="Segoe UI"/>
+              </a:rPr>
+              <a:t>•  </a:t>
+            </a:r>
+            <a:r>
+              <a:rPr sz="1150" b="1" u="none">
+                <a:solidFill>
+                  <a:srgbClr val="0B2545"/>
+                </a:solidFill>
+                <a:latin typeface="Segoe UI"/>
+              </a:rPr>
+              <a:t>Live Prototype Demo: </a:t>
+            </a:r>
+            <a:r>
+              <a:rPr sz="1150" b="1" u="sng">
+                <a:solidFill>
+                  <a:srgbClr val="1D4ED8"/>
+                </a:solidFill>
+                <a:latin typeface="Segoe UI"/>
+                <a:hlinkClick r:id="rId3"/>
+              </a:rPr>
+              <a:t>https://planbridge-ai.streamlit.app</a:t>
+            </a:r>
+          </a:p>
+        </p:txBody>
+      </p:sp>
+      <p:sp>
+        <p:nvSpPr>
+          <p:cNvPr id="6" name="Rounded Rectangle 5"/>
+          <p:cNvSpPr/>
+          <p:nvPr/>
+        </p:nvSpPr>
+        <p:spPr>
+          <a:xfrm>
+            <a:off x="731520" y="6217920"/>
+            <a:ext cx="6400800" cy="438912"/>
+          </a:xfrm>
+          <a:prstGeom prst="roundRect">
+            <a:avLst/>
+          </a:prstGeom>
+          <a:solidFill>
+            <a:srgbClr val="0B2545"/>
+          </a:solidFill>
+          <a:ln w="12700">
+            <a:solidFill>
+              <a:srgbClr val="C25E00"/>
+            </a:solidFill>
+          </a:ln>
+        </p:spPr>
+        <p:style>
+          <a:lnRef idx="1">
+            <a:schemeClr val="accent1"/>
+          </a:lnRef>
+          <a:fillRef idx="3">
+            <a:schemeClr val="accent1"/>
+          </a:fillRef>
+          <a:effectRef idx="2">
+            <a:schemeClr val="accent1"/>
+          </a:effectRef>
+          <a:fontRef idx="minor">
+            <a:schemeClr val="lt1"/>
+          </a:fontRef>
+        </p:style>
+        <p:txBody>
+          <a:bodyPr rtlCol="0" anchor="ctr" wrap="square" lIns="36576" rIns="36576" tIns="36576" bIns="36576"/>
+          <a:lstStyle/>
+          <a:p>
+            <a:pPr algn="ctr"/>
+            <a:r>
+              <a:rPr sz="1000" b="1" u="none">
+                <a:solidFill>
+                  <a:srgbClr val="FFFFFF"/>
+                </a:solidFill>
+                <a:latin typeface="Segoe UI"/>
+              </a:rPr>
+              <a:t>🌐 LIVE INTERACTIVE CLOUD DEMO:  </a:t>
+            </a:r>
+            <a:r>
+              <a:rPr sz="1000" b="1" u="sng">
+                <a:solidFill>
+                  <a:srgbClr val="FB923C"/>
+                </a:solidFill>
+                <a:latin typeface="Segoe UI"/>
+                <a:hlinkClick r:id="rId3"/>
+              </a:rPr>
+              <a:t>https://planbridge-ai.streamlit.app</a:t>
             </a:r>
           </a:p>
         </p:txBody>
       </p:sp>
       <p:pic>
         <p:nvPicPr>
-          <p:cNvPr id="6" name="Picture 5" descr="slide1_hero_graphic.png"/>
+          <p:cNvPr id="7" name="Picture 6" descr="slide1_hero_graphic.png"/>
           <p:cNvPicPr>
             <a:picLocks noChangeAspect="1"/>
           </p:cNvPicPr>
           <p:nvPr/>
         </p:nvPicPr>
         <p:blipFill>
-          <a:blip r:embed="rId3"/>
+          <a:blip r:embed="rId4"/>
           <a:stretch>
             <a:fillRect/>
           </a:stretch>

</xml_diff>